<commit_message>
Finalise decisions, regenerate deck and quote workbook (total 18871.95)
</commit_message>
<xml_diff>
--- a/submit/VBot_slide.pptx
+++ b/submit/VBot_slide.pptx
@@ -215,16 +215,16 @@
                 <c:ptCount val="8"/>
                 <c:lvl>
                   <c:pt idx="0">
-                    <c:v>Ảnh cấp 5</c:v>
+                    <c:v>SRE 1,0 FTE</c:v>
                   </c:pt>
                   <c:pt idx="1">
-                    <c:v>SRE 1,0 FTE</c:v>
+                    <c:v>Sonnet token ra</c:v>
                   </c:pt>
                   <c:pt idx="2">
-                    <c:v>Sonnet token ra</c:v>
+                    <c:v>Sonnet token vào</c:v>
                   </c:pt>
                   <c:pt idx="3">
-                    <c:v>Sonnet token vào</c:v>
+                    <c:v>Ảnh cấp 5 (1,1/request)</c:v>
                   </c:pt>
                   <c:pt idx="4">
                     <c:v>LLMOps 0,5 FTE</c:v>
@@ -249,16 +249,16 @@
                 <c:formatCode>General</c:formatCode>
                 <c:ptCount val="8"/>
                 <c:pt idx="0">
-                  <c:v>4532</c:v>
+                  <c:v>3500</c:v>
                 </c:pt>
                 <c:pt idx="1">
-                  <c:v>3500</c:v>
+                  <c:v>3312.93</c:v>
                 </c:pt>
                 <c:pt idx="2">
-                  <c:v>3312.93</c:v>
+                  <c:v>2988.67</c:v>
                 </c:pt>
                 <c:pt idx="3">
-                  <c:v>2988.67</c:v>
+                  <c:v>2420</c:v>
                 </c:pt>
                 <c:pt idx="4">
                   <c:v>1750</c:v>
@@ -2675,7 +2675,7 @@
                 <a:ea typeface="Cambria" pitchFamily="34" charset="-122"/>
                 <a:cs typeface="Cambria" pitchFamily="34" charset="-120"/>
               </a:rPr>
-              <a:t>$20.987 / tháng</a:t>
+              <a:t>$18.872 / tháng</a:t>
             </a:r>
             <a:endParaRPr lang="en-US" sz="3000" dirty="0"/>
           </a:p>
@@ -2714,7 +2714,7 @@
                 <a:ea typeface="Calibri" pitchFamily="34" charset="-122"/>
                 <a:cs typeface="Calibri" pitchFamily="34" charset="-120"/>
               </a:rPr>
-              <a:t>$10,49 mỗi người dùng · giá niêm yết, không free tier</a:t>
+              <a:t>$9,44 mỗi người dùng · giá niêm yết, không free tier</a:t>
             </a:r>
             <a:endParaRPr lang="en-US" sz="1300" dirty="0"/>
           </a:p>
@@ -4876,7 +4876,7 @@
                 <a:ea typeface="Calibri" pitchFamily="34" charset="-122"/>
                 <a:cs typeface="Calibri" pitchFamily="34" charset="-120"/>
               </a:rPr>
-              <a:t>$10,49 mỗi người dùng mỗi tháng</a:t>
+              <a:t>$9,44 mỗi người dùng mỗi tháng</a:t>
             </a:r>
             <a:pPr indent="0" marL="0">
               <a:buNone/>
@@ -5000,7 +5000,7 @@
                 <a:ea typeface="Calibri" pitchFamily="34" charset="-122"/>
                 <a:cs typeface="Calibri" pitchFamily="34" charset="-120"/>
               </a:rPr>
-              <a:t>$20.987 mỗi tháng, $10,49 mỗi người dùng. Không tính nhân sự: $15.537.</a:t>
+              <a:t>$18.872 mỗi tháng, $9,44 mỗi người dùng. Không tính nhân sự: $13.422.</a:t>
             </a:r>
             <a:endParaRPr lang="en-US" sz="1300" dirty="0"/>
           </a:p>
@@ -5144,7 +5144,7 @@
                 <a:ea typeface="Cambria" pitchFamily="34" charset="-122"/>
                 <a:cs typeface="Cambria" pitchFamily="34" charset="-120"/>
               </a:rPr>
-              <a:t>$11.807</a:t>
+              <a:t>$9.695</a:t>
             </a:r>
             <a:endParaRPr lang="en-US" sz="2000" dirty="0"/>
           </a:p>
@@ -5183,7 +5183,7 @@
                 <a:ea typeface="Calibri" pitchFamily="34" charset="-122"/>
                 <a:cs typeface="Calibri" pitchFamily="34" charset="-120"/>
               </a:rPr>
-              <a:t>LLM (token + ảnh) · 56,3%</a:t>
+              <a:t>LLM (token + ảnh) · 51,4%</a:t>
             </a:r>
             <a:endParaRPr lang="en-US" sz="1100" dirty="0"/>
           </a:p>
@@ -5288,7 +5288,7 @@
                 <a:ea typeface="Calibri" pitchFamily="34" charset="-122"/>
                 <a:cs typeface="Calibri" pitchFamily="34" charset="-120"/>
               </a:rPr>
-              <a:t>Nhân sự vận hành · 26,0%</a:t>
+              <a:t>Nhân sự vận hành · 28,9%</a:t>
             </a:r>
             <a:endParaRPr lang="en-US" sz="1100" dirty="0"/>
           </a:p>
@@ -5354,7 +5354,7 @@
                 <a:ea typeface="Cambria" pitchFamily="34" charset="-122"/>
                 <a:cs typeface="Cambria" pitchFamily="34" charset="-120"/>
               </a:rPr>
-              <a:t>$3.730</a:t>
+              <a:t>$3.727</a:t>
             </a:r>
             <a:endParaRPr lang="en-US" sz="2000" dirty="0"/>
           </a:p>
@@ -5393,7 +5393,7 @@
                 <a:ea typeface="Calibri" pitchFamily="34" charset="-122"/>
                 <a:cs typeface="Calibri" pitchFamily="34" charset="-120"/>
               </a:rPr>
-              <a:t>Hạ tầng còn lại · 17,8%</a:t>
+              <a:t>Hạ tầng còn lại · 19,7%</a:t>
             </a:r>
             <a:endParaRPr lang="en-US" sz="1100" dirty="0"/>
           </a:p>
@@ -5432,7 +5432,7 @@
                 <a:ea typeface="Calibri" pitchFamily="34" charset="-122"/>
                 <a:cs typeface="Calibri" pitchFamily="34" charset="-120"/>
               </a:rPr>
-              <a:t>Phần A $11.924 · B $2.872 · C $6.191</a:t>
+              <a:t>Phần A $9.812 · B $2.874 · C $6.186</a:t>
             </a:r>
             <a:endParaRPr lang="en-US" sz="1050" dirty="0"/>
           </a:p>
@@ -5806,6 +5806,27 @@
                 <a:cs typeface="Calibri" pitchFamily="34" charset="-120"/>
               </a:rPr>
               <a:t>Tách tỉ lệ cache ghi/đọc theo cấp: −$1.004.</a:t>
+            </a:r>
+            <a:endParaRPr lang="en-US" sz="1100" dirty="0"/>
+          </a:p>
+          <a:p>
+            <a:pPr marL="342900" indent="-342900">
+              <a:spcAft>
+                <a:spcPts val="400"/>
+              </a:spcAft>
+              <a:buSzPct val="100000"/>
+              <a:buChar char="•"/>
+            </a:pPr>
+            <a:r>
+              <a:rPr lang="en-US" sz="1100" dirty="0">
+                <a:solidFill>
+                  <a:srgbClr val="13222D"/>
+                </a:solidFill>
+                <a:latin typeface="Calibri" pitchFamily="34" charset="0"/>
+                <a:ea typeface="Calibri" pitchFamily="34" charset="-122"/>
+                <a:cs typeface="Calibri" pitchFamily="34" charset="-120"/>
+              </a:rPr>
+              <a:t>Ảnh cấp 5: 1 ảnh nháp, trung bình 1,1 ảnh/request: −$2.112.</a:t>
             </a:r>
             <a:endParaRPr lang="en-US" sz="1100" dirty="0"/>
           </a:p>
@@ -6104,418 +6125,6 @@
                           <a:ea typeface="Calibri" pitchFamily="34" charset="-122"/>
                           <a:cs typeface="Calibri" pitchFamily="34" charset="-120"/>
                         </a:rPr>
-                        <a:t>Ảnh cấp 5: 1 ảnh nháp thay vì 2</a:t>
-                      </a:r>
-                      <a:endParaRPr lang="en-US" sz="1050" dirty="0">
-                        <a:latin typeface="Calibri" charset="0"/>
-                        <a:ea typeface="Calibri" charset="0"/>
-                        <a:cs typeface="Calibri" charset="0"/>
-                      </a:endParaRPr>
-                    </a:p>
-                  </a:txBody>
-                  <a:tcPr marL="91440" marR="91440" marT="45720" marB="45720" anchor="ctr">
-                    <a:lnL w="6350" cap="flat" cmpd="sng" algn="ctr">
-                      <a:solidFill>
-                        <a:srgbClr val="D2DCE3"/>
-                      </a:solidFill>
-                      <a:prstDash val="solid"/>
-                      <a:round/>
-                      <a:headEnd type="none" w="med" len="med"/>
-                      <a:tailEnd type="none" w="med" len="med"/>
-                    </a:lnL>
-                    <a:lnR w="6350" cap="flat" cmpd="sng" algn="ctr">
-                      <a:solidFill>
-                        <a:srgbClr val="D2DCE3"/>
-                      </a:solidFill>
-                      <a:prstDash val="solid"/>
-                      <a:round/>
-                      <a:headEnd type="none" w="med" len="med"/>
-                      <a:tailEnd type="none" w="med" len="med"/>
-                    </a:lnR>
-                    <a:lnT w="6350" cap="flat" cmpd="sng" algn="ctr">
-                      <a:solidFill>
-                        <a:srgbClr val="D2DCE3"/>
-                      </a:solidFill>
-                      <a:prstDash val="solid"/>
-                      <a:round/>
-                      <a:headEnd type="none" w="med" len="med"/>
-                      <a:tailEnd type="none" w="med" len="med"/>
-                    </a:lnT>
-                    <a:lnB w="6350" cap="flat" cmpd="sng" algn="ctr">
-                      <a:solidFill>
-                        <a:srgbClr val="D2DCE3"/>
-                      </a:solidFill>
-                      <a:prstDash val="solid"/>
-                      <a:round/>
-                      <a:headEnd type="none" w="med" len="med"/>
-                      <a:tailEnd type="none" w="med" len="med"/>
-                    </a:lnB>
-                    <a:solidFill>
-                      <a:srgbClr val="FFFFFF"/>
-                    </a:solidFill>
-                  </a:tcPr>
-                </a:tc>
-                <a:tc>
-                  <a:txBody>
-                    <a:bodyPr/>
-                    <a:lstStyle/>
-                    <a:p>
-                      <a:pPr algn="r" indent="0" marL="0">
-                        <a:buNone/>
-                      </a:pPr>
-                      <a:r>
-                        <a:rPr lang="en-US" sz="1050" b="1" dirty="0">
-                          <a:solidFill>
-                            <a:srgbClr val="15803D"/>
-                          </a:solidFill>
-                          <a:latin typeface="Calibri" pitchFamily="34" charset="0"/>
-                          <a:ea typeface="Calibri" pitchFamily="34" charset="-122"/>
-                          <a:cs typeface="Calibri" pitchFamily="34" charset="-120"/>
-                        </a:rPr>
-                        <a:t>−2.266</a:t>
-                      </a:r>
-                      <a:endParaRPr lang="en-US" sz="1050" dirty="0">
-                        <a:latin typeface="Calibri" charset="0"/>
-                        <a:ea typeface="Calibri" charset="0"/>
-                        <a:cs typeface="Calibri" charset="0"/>
-                      </a:endParaRPr>
-                    </a:p>
-                  </a:txBody>
-                  <a:tcPr marL="91440" marR="91440" marT="45720" marB="45720" anchor="ctr">
-                    <a:lnL w="6350" cap="flat" cmpd="sng" algn="ctr">
-                      <a:solidFill>
-                        <a:srgbClr val="D2DCE3"/>
-                      </a:solidFill>
-                      <a:prstDash val="solid"/>
-                      <a:round/>
-                      <a:headEnd type="none" w="med" len="med"/>
-                      <a:tailEnd type="none" w="med" len="med"/>
-                    </a:lnL>
-                    <a:lnR w="6350" cap="flat" cmpd="sng" algn="ctr">
-                      <a:solidFill>
-                        <a:srgbClr val="D2DCE3"/>
-                      </a:solidFill>
-                      <a:prstDash val="solid"/>
-                      <a:round/>
-                      <a:headEnd type="none" w="med" len="med"/>
-                      <a:tailEnd type="none" w="med" len="med"/>
-                    </a:lnR>
-                    <a:lnT w="6350" cap="flat" cmpd="sng" algn="ctr">
-                      <a:solidFill>
-                        <a:srgbClr val="D2DCE3"/>
-                      </a:solidFill>
-                      <a:prstDash val="solid"/>
-                      <a:round/>
-                      <a:headEnd type="none" w="med" len="med"/>
-                      <a:tailEnd type="none" w="med" len="med"/>
-                    </a:lnT>
-                    <a:lnB w="6350" cap="flat" cmpd="sng" algn="ctr">
-                      <a:solidFill>
-                        <a:srgbClr val="D2DCE3"/>
-                      </a:solidFill>
-                      <a:prstDash val="solid"/>
-                      <a:round/>
-                      <a:headEnd type="none" w="med" len="med"/>
-                      <a:tailEnd type="none" w="med" len="med"/>
-                    </a:lnB>
-                    <a:solidFill>
-                      <a:srgbClr val="FFFFFF"/>
-                    </a:solidFill>
-                  </a:tcPr>
-                </a:tc>
-                <a:tc>
-                  <a:txBody>
-                    <a:bodyPr/>
-                    <a:lstStyle/>
-                    <a:p>
-                      <a:pPr algn="l" indent="0" marL="0">
-                        <a:buNone/>
-                      </a:pPr>
-                      <a:r>
-                        <a:rPr lang="en-US" sz="1050" dirty="0">
-                          <a:solidFill>
-                            <a:srgbClr val="13222D"/>
-                          </a:solidFill>
-                          <a:latin typeface="Calibri" pitchFamily="34" charset="0"/>
-                          <a:ea typeface="Calibri" pitchFamily="34" charset="-122"/>
-                          <a:cs typeface="Calibri" pitchFamily="34" charset="-120"/>
-                        </a:rPr>
-                        <a:t>Người dùng xin thêm khi cần</a:t>
-                      </a:r>
-                      <a:endParaRPr lang="en-US" sz="1050" dirty="0">
-                        <a:latin typeface="Calibri" charset="0"/>
-                        <a:ea typeface="Calibri" charset="0"/>
-                        <a:cs typeface="Calibri" charset="0"/>
-                      </a:endParaRPr>
-                    </a:p>
-                  </a:txBody>
-                  <a:tcPr marL="91440" marR="91440" marT="45720" marB="45720" anchor="ctr">
-                    <a:lnL w="6350" cap="flat" cmpd="sng" algn="ctr">
-                      <a:solidFill>
-                        <a:srgbClr val="D2DCE3"/>
-                      </a:solidFill>
-                      <a:prstDash val="solid"/>
-                      <a:round/>
-                      <a:headEnd type="none" w="med" len="med"/>
-                      <a:tailEnd type="none" w="med" len="med"/>
-                    </a:lnL>
-                    <a:lnR w="6350" cap="flat" cmpd="sng" algn="ctr">
-                      <a:solidFill>
-                        <a:srgbClr val="D2DCE3"/>
-                      </a:solidFill>
-                      <a:prstDash val="solid"/>
-                      <a:round/>
-                      <a:headEnd type="none" w="med" len="med"/>
-                      <a:tailEnd type="none" w="med" len="med"/>
-                    </a:lnR>
-                    <a:lnT w="6350" cap="flat" cmpd="sng" algn="ctr">
-                      <a:solidFill>
-                        <a:srgbClr val="D2DCE3"/>
-                      </a:solidFill>
-                      <a:prstDash val="solid"/>
-                      <a:round/>
-                      <a:headEnd type="none" w="med" len="med"/>
-                      <a:tailEnd type="none" w="med" len="med"/>
-                    </a:lnT>
-                    <a:lnB w="6350" cap="flat" cmpd="sng" algn="ctr">
-                      <a:solidFill>
-                        <a:srgbClr val="D2DCE3"/>
-                      </a:solidFill>
-                      <a:prstDash val="solid"/>
-                      <a:round/>
-                      <a:headEnd type="none" w="med" len="med"/>
-                      <a:tailEnd type="none" w="med" len="med"/>
-                    </a:lnB>
-                    <a:solidFill>
-                      <a:srgbClr val="FFFFFF"/>
-                    </a:solidFill>
-                  </a:tcPr>
-                </a:tc>
-              </a:tr>
-              <a:tr h="384048">
-                <a:tc>
-                  <a:txBody>
-                    <a:bodyPr/>
-                    <a:lstStyle/>
-                    <a:p>
-                      <a:pPr algn="l" indent="0" marL="0">
-                        <a:buNone/>
-                      </a:pPr>
-                      <a:r>
-                        <a:rPr lang="en-US" sz="1050" dirty="0">
-                          <a:solidFill>
-                            <a:srgbClr val="13222D"/>
-                          </a:solidFill>
-                          <a:latin typeface="Calibri" pitchFamily="34" charset="0"/>
-                          <a:ea typeface="Calibri" pitchFamily="34" charset="-122"/>
-                          <a:cs typeface="Calibri" pitchFamily="34" charset="-120"/>
-                        </a:rPr>
-                        <a:t>Gộp LLMOps 0,5 FTE vào SRE</a:t>
-                      </a:r>
-                      <a:endParaRPr lang="en-US" sz="1050" dirty="0">
-                        <a:latin typeface="Calibri" charset="0"/>
-                        <a:ea typeface="Calibri" charset="0"/>
-                        <a:cs typeface="Calibri" charset="0"/>
-                      </a:endParaRPr>
-                    </a:p>
-                  </a:txBody>
-                  <a:tcPr marL="91440" marR="91440" marT="45720" marB="45720" anchor="ctr">
-                    <a:lnL w="6350" cap="flat" cmpd="sng" algn="ctr">
-                      <a:solidFill>
-                        <a:srgbClr val="D2DCE3"/>
-                      </a:solidFill>
-                      <a:prstDash val="solid"/>
-                      <a:round/>
-                      <a:headEnd type="none" w="med" len="med"/>
-                      <a:tailEnd type="none" w="med" len="med"/>
-                    </a:lnL>
-                    <a:lnR w="6350" cap="flat" cmpd="sng" algn="ctr">
-                      <a:solidFill>
-                        <a:srgbClr val="D2DCE3"/>
-                      </a:solidFill>
-                      <a:prstDash val="solid"/>
-                      <a:round/>
-                      <a:headEnd type="none" w="med" len="med"/>
-                      <a:tailEnd type="none" w="med" len="med"/>
-                    </a:lnR>
-                    <a:lnT w="6350" cap="flat" cmpd="sng" algn="ctr">
-                      <a:solidFill>
-                        <a:srgbClr val="D2DCE3"/>
-                      </a:solidFill>
-                      <a:prstDash val="solid"/>
-                      <a:round/>
-                      <a:headEnd type="none" w="med" len="med"/>
-                      <a:tailEnd type="none" w="med" len="med"/>
-                    </a:lnT>
-                    <a:lnB w="6350" cap="flat" cmpd="sng" algn="ctr">
-                      <a:solidFill>
-                        <a:srgbClr val="D2DCE3"/>
-                      </a:solidFill>
-                      <a:prstDash val="solid"/>
-                      <a:round/>
-                      <a:headEnd type="none" w="med" len="med"/>
-                      <a:tailEnd type="none" w="med" len="med"/>
-                    </a:lnB>
-                    <a:solidFill>
-                      <a:srgbClr val="F2F6F9"/>
-                    </a:solidFill>
-                  </a:tcPr>
-                </a:tc>
-                <a:tc>
-                  <a:txBody>
-                    <a:bodyPr/>
-                    <a:lstStyle/>
-                    <a:p>
-                      <a:pPr algn="r" indent="0" marL="0">
-                        <a:buNone/>
-                      </a:pPr>
-                      <a:r>
-                        <a:rPr lang="en-US" sz="1050" b="1" dirty="0">
-                          <a:solidFill>
-                            <a:srgbClr val="15803D"/>
-                          </a:solidFill>
-                          <a:latin typeface="Calibri" pitchFamily="34" charset="0"/>
-                          <a:ea typeface="Calibri" pitchFamily="34" charset="-122"/>
-                          <a:cs typeface="Calibri" pitchFamily="34" charset="-120"/>
-                        </a:rPr>
-                        <a:t>−1.750</a:t>
-                      </a:r>
-                      <a:endParaRPr lang="en-US" sz="1050" dirty="0">
-                        <a:latin typeface="Calibri" charset="0"/>
-                        <a:ea typeface="Calibri" charset="0"/>
-                        <a:cs typeface="Calibri" charset="0"/>
-                      </a:endParaRPr>
-                    </a:p>
-                  </a:txBody>
-                  <a:tcPr marL="91440" marR="91440" marT="45720" marB="45720" anchor="ctr">
-                    <a:lnL w="6350" cap="flat" cmpd="sng" algn="ctr">
-                      <a:solidFill>
-                        <a:srgbClr val="D2DCE3"/>
-                      </a:solidFill>
-                      <a:prstDash val="solid"/>
-                      <a:round/>
-                      <a:headEnd type="none" w="med" len="med"/>
-                      <a:tailEnd type="none" w="med" len="med"/>
-                    </a:lnL>
-                    <a:lnR w="6350" cap="flat" cmpd="sng" algn="ctr">
-                      <a:solidFill>
-                        <a:srgbClr val="D2DCE3"/>
-                      </a:solidFill>
-                      <a:prstDash val="solid"/>
-                      <a:round/>
-                      <a:headEnd type="none" w="med" len="med"/>
-                      <a:tailEnd type="none" w="med" len="med"/>
-                    </a:lnR>
-                    <a:lnT w="6350" cap="flat" cmpd="sng" algn="ctr">
-                      <a:solidFill>
-                        <a:srgbClr val="D2DCE3"/>
-                      </a:solidFill>
-                      <a:prstDash val="solid"/>
-                      <a:round/>
-                      <a:headEnd type="none" w="med" len="med"/>
-                      <a:tailEnd type="none" w="med" len="med"/>
-                    </a:lnT>
-                    <a:lnB w="6350" cap="flat" cmpd="sng" algn="ctr">
-                      <a:solidFill>
-                        <a:srgbClr val="D2DCE3"/>
-                      </a:solidFill>
-                      <a:prstDash val="solid"/>
-                      <a:round/>
-                      <a:headEnd type="none" w="med" len="med"/>
-                      <a:tailEnd type="none" w="med" len="med"/>
-                    </a:lnB>
-                    <a:solidFill>
-                      <a:srgbClr val="F2F6F9"/>
-                    </a:solidFill>
-                  </a:tcPr>
-                </a:tc>
-                <a:tc>
-                  <a:txBody>
-                    <a:bodyPr/>
-                    <a:lstStyle/>
-                    <a:p>
-                      <a:pPr algn="l" indent="0" marL="0">
-                        <a:buNone/>
-                      </a:pPr>
-                      <a:r>
-                        <a:rPr lang="en-US" sz="1050" dirty="0">
-                          <a:solidFill>
-                            <a:srgbClr val="13222D"/>
-                          </a:solidFill>
-                          <a:latin typeface="Calibri" pitchFamily="34" charset="0"/>
-                          <a:ea typeface="Calibri" pitchFamily="34" charset="-122"/>
-                          <a:cs typeface="Calibri" pitchFamily="34" charset="-120"/>
-                        </a:rPr>
-                        <a:t>Quyết định nhân sự</a:t>
-                      </a:r>
-                      <a:endParaRPr lang="en-US" sz="1050" dirty="0">
-                        <a:latin typeface="Calibri" charset="0"/>
-                        <a:ea typeface="Calibri" charset="0"/>
-                        <a:cs typeface="Calibri" charset="0"/>
-                      </a:endParaRPr>
-                    </a:p>
-                  </a:txBody>
-                  <a:tcPr marL="91440" marR="91440" marT="45720" marB="45720" anchor="ctr">
-                    <a:lnL w="6350" cap="flat" cmpd="sng" algn="ctr">
-                      <a:solidFill>
-                        <a:srgbClr val="D2DCE3"/>
-                      </a:solidFill>
-                      <a:prstDash val="solid"/>
-                      <a:round/>
-                      <a:headEnd type="none" w="med" len="med"/>
-                      <a:tailEnd type="none" w="med" len="med"/>
-                    </a:lnL>
-                    <a:lnR w="6350" cap="flat" cmpd="sng" algn="ctr">
-                      <a:solidFill>
-                        <a:srgbClr val="D2DCE3"/>
-                      </a:solidFill>
-                      <a:prstDash val="solid"/>
-                      <a:round/>
-                      <a:headEnd type="none" w="med" len="med"/>
-                      <a:tailEnd type="none" w="med" len="med"/>
-                    </a:lnR>
-                    <a:lnT w="6350" cap="flat" cmpd="sng" algn="ctr">
-                      <a:solidFill>
-                        <a:srgbClr val="D2DCE3"/>
-                      </a:solidFill>
-                      <a:prstDash val="solid"/>
-                      <a:round/>
-                      <a:headEnd type="none" w="med" len="med"/>
-                      <a:tailEnd type="none" w="med" len="med"/>
-                    </a:lnT>
-                    <a:lnB w="6350" cap="flat" cmpd="sng" algn="ctr">
-                      <a:solidFill>
-                        <a:srgbClr val="D2DCE3"/>
-                      </a:solidFill>
-                      <a:prstDash val="solid"/>
-                      <a:round/>
-                      <a:headEnd type="none" w="med" len="med"/>
-                      <a:tailEnd type="none" w="med" len="med"/>
-                    </a:lnB>
-                    <a:solidFill>
-                      <a:srgbClr val="F2F6F9"/>
-                    </a:solidFill>
-                  </a:tcPr>
-                </a:tc>
-              </a:tr>
-              <a:tr h="384048">
-                <a:tc>
-                  <a:txBody>
-                    <a:bodyPr/>
-                    <a:lstStyle/>
-                    <a:p>
-                      <a:pPr algn="l" indent="0" marL="0">
-                        <a:buNone/>
-                      </a:pPr>
-                      <a:r>
-                        <a:rPr lang="en-US" sz="1050" dirty="0">
-                          <a:solidFill>
-                            <a:srgbClr val="13222D"/>
-                          </a:solidFill>
-                          <a:latin typeface="Calibri" pitchFamily="34" charset="0"/>
-                          <a:ea typeface="Calibri" pitchFamily="34" charset="-122"/>
-                          <a:cs typeface="Calibri" pitchFamily="34" charset="-120"/>
-                        </a:rPr>
                         <a:t>Cache cấp 4 đọc 85%, ghi 15%</a:t>
                       </a:r>
                       <a:endParaRPr lang="en-US" sz="1050" dirty="0">
@@ -7359,7 +6968,7 @@
                 <a:ea typeface="Calibri" pitchFamily="34" charset="-122"/>
                 <a:cs typeface="Calibri" pitchFamily="34" charset="-120"/>
               </a:rPr>
-              <a:t>Chỉ áp dụng "1 ảnh nháp": $20.987 → $18.721.</a:t>
+              <a:t>Sau các quyết định chốt: $20.987 → $18.872 mỗi tháng.</a:t>
             </a:r>
             <a:endParaRPr lang="en-US" sz="1200" dirty="0"/>
           </a:p>
@@ -7677,7 +7286,7 @@
                 <a:ea typeface="Calibri" pitchFamily="34" charset="-122"/>
                 <a:cs typeface="Calibri" pitchFamily="34" charset="-120"/>
               </a:rPr>
-              <a:t>H1: hồ sơ Bedrock global xử lý ở region bất kỳ, Guardrails dùng cross-Region, ảnh gọi ở us-west-2. Hồ sơ geo APAC: +$727.</a:t>
+              <a:t>H1: đã chốt giữ hồ sơ Bedrock global (cùng một cloud AWS, không lưu dữ liệu). Guardrails dùng cross-Region và ảnh gọi ở us-west-2, nên có thể bị chất vấn về nơi xử lý.</a:t>
             </a:r>
             <a:endParaRPr lang="en-US" sz="1150" dirty="0"/>
           </a:p>
@@ -7719,7 +7328,7 @@
                 <a:ea typeface="Calibri" pitchFamily="34" charset="-122"/>
                 <a:cs typeface="Calibri" pitchFamily="34" charset="-120"/>
               </a:rPr>
-              <a:t>Bằng chứng: 33 trong 61 mã ảnh chưa thấy được số Singapore trên trang giá.</a:t>
+              <a:t>Bằng chứng: 66 mã ảnh chưa chụp; 36 chỗ đơn giá Singapore chỉ thấy trong bảng giá JSON, chưa thấy trên trang.</a:t>
             </a:r>
             <a:endParaRPr lang="en-US" sz="1150" dirty="0"/>
           </a:p>
@@ -7824,7 +7433,7 @@
                 <a:ea typeface="Calibri" pitchFamily="34" charset="-122"/>
                 <a:cs typeface="Calibri" pitchFamily="34" charset="-120"/>
               </a:rPr>
-              <a:t>Ước tính ~$35.000 đến $36.000/tháng (+70%).</a:t>
+              <a:t>Ước tính ~$31.400/tháng (+67%).</a:t>
             </a:r>
             <a:endParaRPr lang="en-US" sz="1200" dirty="0"/>
           </a:p>
@@ -7841,7 +7450,7 @@
                 <a:ea typeface="Calibri" pitchFamily="34" charset="-122"/>
                 <a:cs typeface="Calibri" pitchFamily="34" charset="-120"/>
               </a:rPr>
-              <a:t>Phần tăng theo tải (LLM, sandbox, Guardrails, lưu trữ, ~$13.600) nhân đôi; phần cố định (nhân sự, ALB, NAT, DB, ~$7.400) tăng nhẹ. Ước tính của nhóm, chưa tính lại quota.</a:t>
+              <a:t>Phần tăng theo tải (LLM, sandbox, Guardrails, lưu trữ, ~$11.500) nhân đôi; phần cố định (nhân sự, ALB, NAT, DB, ~$7.400) tăng khoảng 15%. Ước tính của nhóm, chưa tính lại quota.</a:t>
             </a:r>
             <a:endParaRPr lang="en-US" sz="1200" dirty="0"/>
           </a:p>
@@ -7950,7 +7559,7 @@
                 <a:ea typeface="Calibri" pitchFamily="34" charset="-122"/>
                 <a:cs typeface="Calibri" pitchFamily="34" charset="-120"/>
               </a:rPr>
-              <a:t>Giá token ±30%: khoảng ±$3.400</a:t>
+              <a:t>Giá LLM ±30%: khoảng ±$2.900</a:t>
             </a:r>
             <a:endParaRPr lang="en-US" sz="1100" dirty="0"/>
           </a:p>
@@ -8499,13 +8108,13 @@
                       <a:r>
                         <a:rPr lang="en-US" sz="1100" b="1" dirty="0">
                           <a:solidFill>
-                            <a:srgbClr val="B42318"/>
+                            <a:srgbClr val="946200"/>
                           </a:solidFill>
                           <a:latin typeface="Calibri" pitchFamily="34" charset="0"/>
                           <a:ea typeface="Calibri" pitchFamily="34" charset="-122"/>
                           <a:cs typeface="Calibri" pitchFamily="34" charset="-120"/>
                         </a:rPr>
-                        <a:t>Rủi ro</a:t>
+                        <a:t>Chưa chứng minh</a:t>
                       </a:r>
                       <a:endParaRPr lang="en-US" sz="1100" dirty="0">
                         <a:latin typeface="Calibri" charset="0"/>
@@ -8573,7 +8182,7 @@
                           <a:ea typeface="Calibri" pitchFamily="34" charset="-122"/>
                           <a:cs typeface="Calibri" pitchFamily="34" charset="-120"/>
                         </a:rPr>
-                        <a:t>Global profile, Guardrails cross-Region, ảnh ở us-west-2 cần chốt</a:t>
+                        <a:t>Đã chốt: AWS, hồ sơ global, không lưu dữ liệu; có thể bị hỏi về nơi xử lý</a:t>
                       </a:r>
                       <a:endParaRPr lang="en-US" sz="1050" dirty="0">
                         <a:latin typeface="Calibri" charset="0"/>
@@ -9397,7 +9006,7 @@
                           <a:ea typeface="Calibri" pitchFamily="34" charset="-122"/>
                           <a:cs typeface="Calibri" pitchFamily="34" charset="-120"/>
                         </a:rPr>
-                        <a:t>SSE-KMS, Presidio, audit 12 tháng; thiếu chính sách lưu</a:t>
+                        <a:t>SSE-KMS, Presidio, audit 12 tháng; chính sách lưu và phân loại đã chốt</a:t>
                       </a:r>
                       <a:endParaRPr lang="en-US" sz="1050" dirty="0">
                         <a:latin typeface="Calibri" charset="0"/>
@@ -10131,7 +9740,7 @@
                 <a:ea typeface="Calibri" pitchFamily="34" charset="-122"/>
                 <a:cs typeface="Calibri" pitchFamily="34" charset="-120"/>
               </a:rPr>
-              <a:t>Còn phải làm: chụp 61 ảnh bằng chứng · đo H6 và H8 · chốt 7 câu hỏi mở (H1, ảnh 1 hay 2, nhân sự, dự phòng, thời hạn lưu dữ liệu).</a:t>
+              <a:t>Đã chốt 7 câu hỏi mở. Còn phải làm: chụp 66 ảnh bằng chứng · đo H6 và H8 · tập bảo vệ 7 phút.</a:t>
             </a:r>
             <a:endParaRPr lang="en-US" sz="1200" dirty="0"/>
           </a:p>
@@ -10458,7 +10067,7 @@
                           <a:ea typeface="Calibri" pitchFamily="34" charset="-122"/>
                           <a:cs typeface="Calibri" pitchFamily="34" charset="-120"/>
                         </a:rPr>
-                        <a:t>11.806,99</a:t>
+                        <a:t>9.694,99</a:t>
                       </a:r>
                       <a:endParaRPr lang="en-US" sz="1050" dirty="0">
                         <a:latin typeface="Calibri" charset="0"/>
@@ -11148,7 +10757,7 @@
                           <a:ea typeface="Calibri" pitchFamily="34" charset="-122"/>
                           <a:cs typeface="Calibri" pitchFamily="34" charset="-120"/>
                         </a:rPr>
-                        <a:t>225,65</a:t>
+                        <a:t>221,24</a:t>
                       </a:r>
                       <a:endParaRPr lang="en-US" sz="1050" dirty="0">
                         <a:latin typeface="Calibri" charset="0"/>
@@ -11562,7 +11171,7 @@
                           <a:ea typeface="Calibri" pitchFamily="34" charset="-122"/>
                           <a:cs typeface="Calibri" pitchFamily="34" charset="-120"/>
                         </a:rPr>
-                        <a:t>129,25</a:t>
+                        <a:t>131,07</a:t>
                       </a:r>
                       <a:endParaRPr lang="en-US" sz="1050" dirty="0">
                         <a:latin typeface="Calibri" charset="0"/>
@@ -12696,7 +12305,7 @@
                           <a:ea typeface="Calibri" pitchFamily="34" charset="-122"/>
                           <a:cs typeface="Calibri" pitchFamily="34" charset="-120"/>
                         </a:rPr>
-                        <a:t>35,27</a:t>
+                        <a:t>35,05</a:t>
                       </a:r>
                       <a:endParaRPr lang="en-US" sz="1050" dirty="0">
                         <a:latin typeface="Calibri" charset="0"/>
@@ -13613,7 +13222,7 @@
                 <a:ea typeface="Calibri" pitchFamily="34" charset="-122"/>
                 <a:cs typeface="Calibri" pitchFamily="34" charset="-120"/>
               </a:rPr>
-              <a:t>TỔNG $20.986,76 / tháng · $10,49 mỗi DAU. Chi tiết từng dòng và bằng chứng: docs/baogia-A/B/C.tsv và evidence/INDEX.md. vector_db tính trong database.</a:t>
+              <a:t>TỔNG $18.871,95 / tháng · $9,44 mỗi DAU. Chi tiết từng dòng và bằng chứng: docs/baogia-A/B/C.tsv và evidence/INDEX.md. vector_db tính trong database.</a:t>
             </a:r>
             <a:endParaRPr lang="en-US" sz="1100" dirty="0"/>
           </a:p>
@@ -16268,7 +15877,7 @@
                           <a:ea typeface="Calibri" pitchFamily="34" charset="-122"/>
                           <a:cs typeface="Calibri" pitchFamily="34" charset="-120"/>
                         </a:rPr>
-                        <a:t>Sonnet 5.5 + 2 ảnh</a:t>
+                        <a:t>Sonnet 5.5 + 1,1 ảnh</a:t>
                       </a:r>
                       <a:endParaRPr lang="en-US" sz="1100" dirty="0">
                         <a:latin typeface="Calibri" charset="0"/>
@@ -21881,7 +21490,7 @@
                           <a:ea typeface="Calibri" pitchFamily="34" charset="-122"/>
                           <a:cs typeface="Calibri" pitchFamily="34" charset="-120"/>
                         </a:rPr>
-                        <a:t>Cộng 2 ảnh/request (Stable Image Core)</a:t>
+                        <a:t>1 ảnh nháp, trung bình 1,1 ảnh/request (Stable Image Core)</a:t>
                       </a:r>
                       <a:endParaRPr lang="en-US" sz="1100" dirty="0">
                         <a:latin typeface="Calibri" charset="0"/>
@@ -24657,7 +24266,7 @@
                 <a:ea typeface="Calibri" pitchFamily="34" charset="-122"/>
                 <a:cs typeface="Calibri" pitchFamily="34" charset="-120"/>
               </a:rPr>
-              <a:t>$129,25/tháng</a:t>
+              <a:t>$131,07/tháng</a:t>
             </a:r>
             <a:endParaRPr lang="en-US" sz="1000" dirty="0"/>
           </a:p>
@@ -25168,7 +24777,7 @@
                 <a:ea typeface="Calibri" pitchFamily="34" charset="-122"/>
                 <a:cs typeface="Calibri" pitchFamily="34" charset="-120"/>
               </a:rPr>
-              <a:t>Audit log 12 tháng ở S3 Object Lock.</a:t>
+              <a:t>Audit log 12 tháng ở S3 Object Lock; log ứng dụng 30 ngày; chat 12 tháng rồi xóa.</a:t>
             </a:r>
             <a:endParaRPr lang="en-US" sz="1150" dirty="0"/>
           </a:p>
@@ -25210,7 +24819,7 @@
                 <a:ea typeface="Calibri" pitchFamily="34" charset="-122"/>
                 <a:cs typeface="Calibri" pitchFamily="34" charset="-120"/>
               </a:rPr>
-              <a:t>Còn thiếu: chính sách phân loại và thời hạn lưu dữ liệu.</a:t>
+              <a:t>Phân loại 3 mức (Công khai, Nội bộ, Mật); mức Mật không ra khỏi AWS. Workspace xóa 90 ngày sau khi khóa tài khoản.</a:t>
             </a:r>
             <a:endParaRPr lang="en-US" sz="1150" dirty="0"/>
           </a:p>

</xml_diff>